<commit_message>
Update laboratory works with detailed reports and materials
</commit_message>
<xml_diff>
--- a/Lab5/pzpi-23-6-diachenko-maksym-lab5/pzpi-23-6-diachenko-maksym-lab5-presentation.pptx
+++ b/Lab5/pzpi-23-6-diachenko-maksym-lab5/pzpi-23-6-diachenko-maksym-lab5-presentation.pptx
@@ -3090,6 +3090,14 @@
 <file path=ppt/slides/slide1.xml><?xml version="1.0" encoding="utf-8"?>
 <p:sld xmlns:a="http://schemas.openxmlformats.org/drawingml/2006/main" xmlns:p="http://schemas.openxmlformats.org/presentationml/2006/main" xmlns:r="http://schemas.openxmlformats.org/officeDocument/2006/relationships">
   <p:cSld>
+    <p:bg>
+      <p:bgPr>
+        <a:solidFill>
+          <a:srgbClr val="F5F8FC"/>
+        </a:solidFill>
+        <a:effectLst/>
+      </p:bgPr>
+    </p:bg>
     <p:spTree>
       <p:nvGrpSpPr>
         <p:cNvPr id="1" name=""/>
@@ -3099,59 +3107,14 @@
       <p:grpSpPr/>
       <p:sp>
         <p:nvSpPr>
-          <p:cNvPr id="2" name="Rectangle 1"/>
-          <p:cNvSpPr/>
-          <p:nvPr/>
-        </p:nvSpPr>
-        <p:spPr>
-          <a:xfrm>
-            <a:off x="0" y="0"/>
-            <a:ext cx="12191695" cy="6858000"/>
-          </a:xfrm>
-          <a:prstGeom prst="rect">
-            <a:avLst/>
-          </a:prstGeom>
-          <a:solidFill>
-            <a:srgbClr val="F5F7FB"/>
-          </a:solidFill>
-          <a:ln>
-            <a:solidFill>
-              <a:srgbClr val="F5F7FB"/>
-            </a:solidFill>
-          </a:ln>
-        </p:spPr>
-        <p:style>
-          <a:lnRef idx="1">
-            <a:schemeClr val="accent1"/>
-          </a:lnRef>
-          <a:fillRef idx="3">
-            <a:schemeClr val="accent1"/>
-          </a:fillRef>
-          <a:effectRef idx="2">
-            <a:schemeClr val="accent1"/>
-          </a:effectRef>
-          <a:fontRef idx="minor">
-            <a:schemeClr val="lt1"/>
-          </a:fontRef>
-        </p:style>
-        <p:txBody>
-          <a:bodyPr rtlCol="0" anchor="ctr"/>
-          <a:lstStyle/>
-          <a:p>
-            <a:pPr algn="ctr"/>
-          </a:p>
-        </p:txBody>
-      </p:sp>
-      <p:sp>
-        <p:nvSpPr>
-          <p:cNvPr id="3" name="TextBox 2"/>
+          <p:cNvPr id="2" name="TextBox 1"/>
           <p:cNvSpPr txBox="1"/>
           <p:nvPr/>
         </p:nvSpPr>
         <p:spPr>
           <a:xfrm>
-            <a:off x="640080" y="457200"/>
-            <a:ext cx="10972800" cy="731520"/>
+            <a:off x="548640" y="365760"/>
+            <a:ext cx="10972800" cy="640080"/>
           </a:xfrm>
           <a:prstGeom prst="rect">
             <a:avLst/>
@@ -3165,74 +3128,28 @@
           <a:lstStyle/>
           <a:p>
             <a:pPr>
-              <a:defRPr sz="3200" b="1">
-                <a:solidFill>
-                  <a:srgbClr val="1F3B60"/>
-                </a:solidFill>
-                <a:latin typeface="Aptos Display"/>
-              </a:defRPr>
-            </a:pPr>
-            <a:r>
-              <a:t>Програмна система аналізу природних ресурсів</a:t>
-            </a:r>
-          </a:p>
-        </p:txBody>
-      </p:sp>
-      <p:sp>
-        <p:nvSpPr>
-          <p:cNvPr id="4" name="Rectangle 3"/>
-          <p:cNvSpPr/>
-          <p:nvPr/>
-        </p:nvSpPr>
-        <p:spPr>
-          <a:xfrm>
-            <a:off x="731520" y="1417320"/>
-            <a:ext cx="10744200" cy="4389120"/>
-          </a:xfrm>
-          <a:prstGeom prst="rect">
-            <a:avLst/>
-          </a:prstGeom>
-          <a:solidFill>
-            <a:srgbClr val="FFFFFF"/>
-          </a:solidFill>
-          <a:ln>
-            <a:solidFill>
-              <a:srgbClr val="BECDE1"/>
-            </a:solidFill>
-          </a:ln>
-        </p:spPr>
-        <p:style>
-          <a:lnRef idx="1">
-            <a:schemeClr val="accent1"/>
-          </a:lnRef>
-          <a:fillRef idx="3">
-            <a:schemeClr val="accent1"/>
-          </a:fillRef>
-          <a:effectRef idx="2">
-            <a:schemeClr val="accent1"/>
-          </a:effectRef>
-          <a:fontRef idx="minor">
-            <a:schemeClr val="lt1"/>
-          </a:fontRef>
-        </p:style>
-        <p:txBody>
-          <a:bodyPr rtlCol="0" anchor="ctr"/>
-          <a:lstStyle/>
-          <a:p>
-            <a:pPr algn="ctr"/>
-          </a:p>
-        </p:txBody>
-      </p:sp>
-      <p:sp>
-        <p:nvSpPr>
-          <p:cNvPr id="5" name="TextBox 4"/>
+              <a:defRPr sz="3000" b="1">
+                <a:solidFill>
+                  <a:srgbClr val="14375A"/>
+                </a:solidFill>
+              </a:defRPr>
+            </a:pPr>
+            <a:r>
+              <a:t>Презентація готового проєкту</a:t>
+            </a:r>
+          </a:p>
+        </p:txBody>
+      </p:sp>
+      <p:sp>
+        <p:nvSpPr>
+          <p:cNvPr id="3" name="TextBox 2"/>
           <p:cNvSpPr txBox="1"/>
           <p:nvPr/>
         </p:nvSpPr>
         <p:spPr>
           <a:xfrm>
-            <a:off x="1005840" y="1691640"/>
-            <a:ext cx="10149840" cy="3749039"/>
+            <a:off x="822960" y="1371600"/>
+            <a:ext cx="10607040" cy="4480560"/>
           </a:xfrm>
           <a:prstGeom prst="rect">
             <a:avLst/>
@@ -3240,34 +3157,66 @@
           <a:noFill/>
         </p:spPr>
         <p:txBody>
-          <a:bodyPr wrap="square">
+          <a:bodyPr wrap="none">
             <a:spAutoFit/>
           </a:bodyPr>
           <a:lstStyle/>
           <a:p>
             <a:pPr>
-              <a:defRPr sz="2200">
-                <a:solidFill>
-                  <a:srgbClr val="1E1E1E"/>
-                </a:solidFill>
-                <a:latin typeface="Aptos"/>
-              </a:defRPr>
-            </a:pPr>
-            <a:r>
-              <a:t>Дяченко Максим, ПЗПІ-23-6</a:t>
-            </a:r>
-          </a:p>
-        </p:txBody>
-      </p:sp>
-      <p:sp>
-        <p:nvSpPr>
-          <p:cNvPr id="6" name="TextBox 5"/>
+              <a:spcAft>
+                <a:spcPts val="1000"/>
+              </a:spcAft>
+              <a:defRPr sz="2300">
+                <a:solidFill>
+                  <a:srgbClr val="232323"/>
+                </a:solidFill>
+              </a:defRPr>
+            </a:pPr>
+            <a:r>
+              <a:t>• Дяченко Максим</a:t>
+            </a:r>
+          </a:p>
+          <a:p>
+            <a:pPr>
+              <a:spcAft>
+                <a:spcPts val="1000"/>
+              </a:spcAft>
+              <a:defRPr sz="2300">
+                <a:solidFill>
+                  <a:srgbClr val="232323"/>
+                </a:solidFill>
+              </a:defRPr>
+            </a:pPr>
+            <a:r>
+              <a:t>• ПЗПІ-23-6</a:t>
+            </a:r>
+          </a:p>
+          <a:p>
+            <a:pPr>
+              <a:spcAft>
+                <a:spcPts val="1000"/>
+              </a:spcAft>
+              <a:defRPr sz="2300">
+                <a:solidFill>
+                  <a:srgbClr val="232323"/>
+                </a:solidFill>
+              </a:defRPr>
+            </a:pPr>
+            <a:r>
+              <a:t>• Архітектура програмного забезпечення</a:t>
+            </a:r>
+          </a:p>
+        </p:txBody>
+      </p:sp>
+      <p:sp>
+        <p:nvSpPr>
+          <p:cNvPr id="4" name="TextBox 3"/>
           <p:cNvSpPr txBox="1"/>
           <p:nvPr/>
         </p:nvSpPr>
         <p:spPr>
           <a:xfrm>
-            <a:off x="11155680" y="6217920"/>
+            <a:off x="11247120" y="6309360"/>
             <a:ext cx="640080" cy="274320"/>
           </a:xfrm>
           <a:prstGeom prst="rect">
@@ -3282,11 +3231,7 @@
           <a:lstStyle/>
           <a:p>
             <a:pPr algn="r">
-              <a:defRPr sz="1400">
-                <a:solidFill>
-                  <a:srgbClr val="505050"/>
-                </a:solidFill>
-              </a:defRPr>
+              <a:defRPr sz="1400"/>
             </a:pPr>
             <a:r>
               <a:t>1</a:t>
@@ -3305,6 +3250,14 @@
 <file path=ppt/slides/slide10.xml><?xml version="1.0" encoding="utf-8"?>
 <p:sld xmlns:a="http://schemas.openxmlformats.org/drawingml/2006/main" xmlns:p="http://schemas.openxmlformats.org/presentationml/2006/main" xmlns:r="http://schemas.openxmlformats.org/officeDocument/2006/relationships">
   <p:cSld>
+    <p:bg>
+      <p:bgPr>
+        <a:solidFill>
+          <a:srgbClr val="F5F8FC"/>
+        </a:solidFill>
+        <a:effectLst/>
+      </p:bgPr>
+    </p:bg>
     <p:spTree>
       <p:nvGrpSpPr>
         <p:cNvPr id="1" name=""/>
@@ -3314,59 +3267,14 @@
       <p:grpSpPr/>
       <p:sp>
         <p:nvSpPr>
-          <p:cNvPr id="2" name="Rectangle 1"/>
-          <p:cNvSpPr/>
-          <p:nvPr/>
-        </p:nvSpPr>
-        <p:spPr>
-          <a:xfrm>
-            <a:off x="0" y="0"/>
-            <a:ext cx="12191695" cy="6858000"/>
-          </a:xfrm>
-          <a:prstGeom prst="rect">
-            <a:avLst/>
-          </a:prstGeom>
-          <a:solidFill>
-            <a:srgbClr val="F5F7FB"/>
-          </a:solidFill>
-          <a:ln>
-            <a:solidFill>
-              <a:srgbClr val="F5F7FB"/>
-            </a:solidFill>
-          </a:ln>
-        </p:spPr>
-        <p:style>
-          <a:lnRef idx="1">
-            <a:schemeClr val="accent1"/>
-          </a:lnRef>
-          <a:fillRef idx="3">
-            <a:schemeClr val="accent1"/>
-          </a:fillRef>
-          <a:effectRef idx="2">
-            <a:schemeClr val="accent1"/>
-          </a:effectRef>
-          <a:fontRef idx="minor">
-            <a:schemeClr val="lt1"/>
-          </a:fontRef>
-        </p:style>
-        <p:txBody>
-          <a:bodyPr rtlCol="0" anchor="ctr"/>
-          <a:lstStyle/>
-          <a:p>
-            <a:pPr algn="ctr"/>
-          </a:p>
-        </p:txBody>
-      </p:sp>
-      <p:sp>
-        <p:nvSpPr>
-          <p:cNvPr id="3" name="TextBox 2"/>
+          <p:cNvPr id="2" name="TextBox 1"/>
           <p:cNvSpPr txBox="1"/>
           <p:nvPr/>
         </p:nvSpPr>
         <p:spPr>
           <a:xfrm>
-            <a:off x="640080" y="457200"/>
-            <a:ext cx="10972800" cy="731520"/>
+            <a:off x="548640" y="365760"/>
+            <a:ext cx="10972800" cy="640080"/>
           </a:xfrm>
           <a:prstGeom prst="rect">
             <a:avLst/>
@@ -3380,11 +3288,10 @@
           <a:lstStyle/>
           <a:p>
             <a:pPr>
-              <a:defRPr sz="3200" b="1">
-                <a:solidFill>
-                  <a:srgbClr val="1F3B60"/>
-                </a:solidFill>
-                <a:latin typeface="Aptos Display"/>
+              <a:defRPr sz="3000" b="1">
+                <a:solidFill>
+                  <a:srgbClr val="14375A"/>
+                </a:solidFill>
               </a:defRPr>
             </a:pPr>
             <a:r>
@@ -3395,59 +3302,14 @@
       </p:sp>
       <p:sp>
         <p:nvSpPr>
-          <p:cNvPr id="4" name="Rectangle 3"/>
-          <p:cNvSpPr/>
-          <p:nvPr/>
-        </p:nvSpPr>
-        <p:spPr>
-          <a:xfrm>
-            <a:off x="731520" y="1417320"/>
-            <a:ext cx="10744200" cy="4389120"/>
-          </a:xfrm>
-          <a:prstGeom prst="rect">
-            <a:avLst/>
-          </a:prstGeom>
-          <a:solidFill>
-            <a:srgbClr val="FFFFFF"/>
-          </a:solidFill>
-          <a:ln>
-            <a:solidFill>
-              <a:srgbClr val="BECDE1"/>
-            </a:solidFill>
-          </a:ln>
-        </p:spPr>
-        <p:style>
-          <a:lnRef idx="1">
-            <a:schemeClr val="accent1"/>
-          </a:lnRef>
-          <a:fillRef idx="3">
-            <a:schemeClr val="accent1"/>
-          </a:fillRef>
-          <a:effectRef idx="2">
-            <a:schemeClr val="accent1"/>
-          </a:effectRef>
-          <a:fontRef idx="minor">
-            <a:schemeClr val="lt1"/>
-          </a:fontRef>
-        </p:style>
-        <p:txBody>
-          <a:bodyPr rtlCol="0" anchor="ctr"/>
-          <a:lstStyle/>
-          <a:p>
-            <a:pPr algn="ctr"/>
-          </a:p>
-        </p:txBody>
-      </p:sp>
-      <p:sp>
-        <p:nvSpPr>
-          <p:cNvPr id="5" name="TextBox 4"/>
+          <p:cNvPr id="3" name="TextBox 2"/>
           <p:cNvSpPr txBox="1"/>
           <p:nvPr/>
         </p:nvSpPr>
         <p:spPr>
           <a:xfrm>
-            <a:off x="1005840" y="1691640"/>
-            <a:ext cx="10149840" cy="3749039"/>
+            <a:off x="822960" y="1371600"/>
+            <a:ext cx="10607040" cy="4480560"/>
           </a:xfrm>
           <a:prstGeom prst="rect">
             <a:avLst/>
@@ -3455,34 +3317,66 @@
           <a:noFill/>
         </p:spPr>
         <p:txBody>
-          <a:bodyPr wrap="square">
+          <a:bodyPr wrap="none">
             <a:spAutoFit/>
           </a:bodyPr>
           <a:lstStyle/>
           <a:p>
             <a:pPr>
-              <a:defRPr sz="2200">
-                <a:solidFill>
-                  <a:srgbClr val="1E1E1E"/>
-                </a:solidFill>
-                <a:latin typeface="Aptos"/>
-              </a:defRPr>
-            </a:pPr>
-            <a:r>
-              <a:t>Проєкт демонструє комплексний підхід до побудови системи аналізу природних ресурсів із web, mobile, backend та scaling-компонентами.</a:t>
-            </a:r>
-          </a:p>
-        </p:txBody>
-      </p:sp>
-      <p:sp>
-        <p:nvSpPr>
-          <p:cNvPr id="6" name="TextBox 5"/>
+              <a:spcAft>
+                <a:spcPts val="1000"/>
+              </a:spcAft>
+              <a:defRPr sz="2300">
+                <a:solidFill>
+                  <a:srgbClr val="232323"/>
+                </a:solidFill>
+              </a:defRPr>
+            </a:pPr>
+            <a:r>
+              <a:t>• проєкт демонструє цілісну архітектуру системи;</a:t>
+            </a:r>
+          </a:p>
+          <a:p>
+            <a:pPr>
+              <a:spcAft>
+                <a:spcPts val="1000"/>
+              </a:spcAft>
+              <a:defRPr sz="2300">
+                <a:solidFill>
+                  <a:srgbClr val="232323"/>
+                </a:solidFill>
+              </a:defRPr>
+            </a:pPr>
+            <a:r>
+              <a:t>• підготовлено Web, mobile, backend та scaling-концепцію;</a:t>
+            </a:r>
+          </a:p>
+          <a:p>
+            <a:pPr>
+              <a:spcAft>
+                <a:spcPts val="1000"/>
+              </a:spcAft>
+              <a:defRPr sz="2300">
+                <a:solidFill>
+                  <a:srgbClr val="232323"/>
+                </a:solidFill>
+              </a:defRPr>
+            </a:pPr>
+            <a:r>
+              <a:t>• система має практичну цінність для аналізу природних ресурсів.</a:t>
+            </a:r>
+          </a:p>
+        </p:txBody>
+      </p:sp>
+      <p:sp>
+        <p:nvSpPr>
+          <p:cNvPr id="4" name="TextBox 3"/>
           <p:cNvSpPr txBox="1"/>
           <p:nvPr/>
         </p:nvSpPr>
         <p:spPr>
           <a:xfrm>
-            <a:off x="11155680" y="6217920"/>
+            <a:off x="11247120" y="6309360"/>
             <a:ext cx="640080" cy="274320"/>
           </a:xfrm>
           <a:prstGeom prst="rect">
@@ -3497,11 +3391,7 @@
           <a:lstStyle/>
           <a:p>
             <a:pPr algn="r">
-              <a:defRPr sz="1400">
-                <a:solidFill>
-                  <a:srgbClr val="505050"/>
-                </a:solidFill>
-              </a:defRPr>
+              <a:defRPr sz="1400"/>
             </a:pPr>
             <a:r>
               <a:t>10</a:t>
@@ -3520,6 +3410,14 @@
 <file path=ppt/slides/slide2.xml><?xml version="1.0" encoding="utf-8"?>
 <p:sld xmlns:a="http://schemas.openxmlformats.org/drawingml/2006/main" xmlns:p="http://schemas.openxmlformats.org/presentationml/2006/main" xmlns:r="http://schemas.openxmlformats.org/officeDocument/2006/relationships">
   <p:cSld>
+    <p:bg>
+      <p:bgPr>
+        <a:solidFill>
+          <a:srgbClr val="F5F8FC"/>
+        </a:solidFill>
+        <a:effectLst/>
+      </p:bgPr>
+    </p:bg>
     <p:spTree>
       <p:nvGrpSpPr>
         <p:cNvPr id="1" name=""/>
@@ -3529,59 +3427,14 @@
       <p:grpSpPr/>
       <p:sp>
         <p:nvSpPr>
-          <p:cNvPr id="2" name="Rectangle 1"/>
-          <p:cNvSpPr/>
-          <p:nvPr/>
-        </p:nvSpPr>
-        <p:spPr>
-          <a:xfrm>
-            <a:off x="0" y="0"/>
-            <a:ext cx="12191695" cy="6858000"/>
-          </a:xfrm>
-          <a:prstGeom prst="rect">
-            <a:avLst/>
-          </a:prstGeom>
-          <a:solidFill>
-            <a:srgbClr val="F5F7FB"/>
-          </a:solidFill>
-          <a:ln>
-            <a:solidFill>
-              <a:srgbClr val="F5F7FB"/>
-            </a:solidFill>
-          </a:ln>
-        </p:spPr>
-        <p:style>
-          <a:lnRef idx="1">
-            <a:schemeClr val="accent1"/>
-          </a:lnRef>
-          <a:fillRef idx="3">
-            <a:schemeClr val="accent1"/>
-          </a:fillRef>
-          <a:effectRef idx="2">
-            <a:schemeClr val="accent1"/>
-          </a:effectRef>
-          <a:fontRef idx="minor">
-            <a:schemeClr val="lt1"/>
-          </a:fontRef>
-        </p:style>
-        <p:txBody>
-          <a:bodyPr rtlCol="0" anchor="ctr"/>
-          <a:lstStyle/>
-          <a:p>
-            <a:pPr algn="ctr"/>
-          </a:p>
-        </p:txBody>
-      </p:sp>
-      <p:sp>
-        <p:nvSpPr>
-          <p:cNvPr id="3" name="TextBox 2"/>
+          <p:cNvPr id="2" name="TextBox 1"/>
           <p:cNvSpPr txBox="1"/>
           <p:nvPr/>
         </p:nvSpPr>
         <p:spPr>
           <a:xfrm>
-            <a:off x="640080" y="457200"/>
-            <a:ext cx="10972800" cy="731520"/>
+            <a:off x="548640" y="365760"/>
+            <a:ext cx="10972800" cy="640080"/>
           </a:xfrm>
           <a:prstGeom prst="rect">
             <a:avLst/>
@@ -3595,11 +3448,10 @@
           <a:lstStyle/>
           <a:p>
             <a:pPr>
-              <a:defRPr sz="3200" b="1">
-                <a:solidFill>
-                  <a:srgbClr val="1F3B60"/>
-                </a:solidFill>
-                <a:latin typeface="Aptos Display"/>
+              <a:defRPr sz="3000" b="1">
+                <a:solidFill>
+                  <a:srgbClr val="14375A"/>
+                </a:solidFill>
               </a:defRPr>
             </a:pPr>
             <a:r>
@@ -3610,59 +3462,14 @@
       </p:sp>
       <p:sp>
         <p:nvSpPr>
-          <p:cNvPr id="4" name="Rectangle 3"/>
-          <p:cNvSpPr/>
-          <p:nvPr/>
-        </p:nvSpPr>
-        <p:spPr>
-          <a:xfrm>
-            <a:off x="731520" y="1417320"/>
-            <a:ext cx="10744200" cy="4389120"/>
-          </a:xfrm>
-          <a:prstGeom prst="rect">
-            <a:avLst/>
-          </a:prstGeom>
-          <a:solidFill>
-            <a:srgbClr val="FFFFFF"/>
-          </a:solidFill>
-          <a:ln>
-            <a:solidFill>
-              <a:srgbClr val="BECDE1"/>
-            </a:solidFill>
-          </a:ln>
-        </p:spPr>
-        <p:style>
-          <a:lnRef idx="1">
-            <a:schemeClr val="accent1"/>
-          </a:lnRef>
-          <a:fillRef idx="3">
-            <a:schemeClr val="accent1"/>
-          </a:fillRef>
-          <a:effectRef idx="2">
-            <a:schemeClr val="accent1"/>
-          </a:effectRef>
-          <a:fontRef idx="minor">
-            <a:schemeClr val="lt1"/>
-          </a:fontRef>
-        </p:style>
-        <p:txBody>
-          <a:bodyPr rtlCol="0" anchor="ctr"/>
-          <a:lstStyle/>
-          <a:p>
-            <a:pPr algn="ctr"/>
-          </a:p>
-        </p:txBody>
-      </p:sp>
-      <p:sp>
-        <p:nvSpPr>
-          <p:cNvPr id="5" name="TextBox 4"/>
+          <p:cNvPr id="3" name="TextBox 2"/>
           <p:cNvSpPr txBox="1"/>
           <p:nvPr/>
         </p:nvSpPr>
         <p:spPr>
           <a:xfrm>
-            <a:off x="1005840" y="1691640"/>
-            <a:ext cx="10149840" cy="3749039"/>
+            <a:off x="822960" y="1371600"/>
+            <a:ext cx="10607040" cy="4480560"/>
           </a:xfrm>
           <a:prstGeom prst="rect">
             <a:avLst/>
@@ -3670,34 +3477,66 @@
           <a:noFill/>
         </p:spPr>
         <p:txBody>
-          <a:bodyPr wrap="square">
+          <a:bodyPr wrap="none">
             <a:spAutoFit/>
           </a:bodyPr>
           <a:lstStyle/>
           <a:p>
             <a:pPr>
-              <a:defRPr sz="2200">
-                <a:solidFill>
-                  <a:srgbClr val="1E1E1E"/>
-                </a:solidFill>
-                <a:latin typeface="Aptos"/>
-              </a:defRPr>
-            </a:pPr>
-            <a:r>
-              <a:t>Дані про природні ресурси часто зберігаються у різних джерелах: звітах, таблицях, локальних системах. Це ускладнює аналіз і прийняття рішень.</a:t>
-            </a:r>
-          </a:p>
-        </p:txBody>
-      </p:sp>
-      <p:sp>
-        <p:nvSpPr>
-          <p:cNvPr id="6" name="TextBox 5"/>
+              <a:spcAft>
+                <a:spcPts val="1000"/>
+              </a:spcAft>
+              <a:defRPr sz="2300">
+                <a:solidFill>
+                  <a:srgbClr val="232323"/>
+                </a:solidFill>
+              </a:defRPr>
+            </a:pPr>
+            <a:r>
+              <a:t>• дані про природні ресурси зберігаються у різних джерелах;</a:t>
+            </a:r>
+          </a:p>
+          <a:p>
+            <a:pPr>
+              <a:spcAft>
+                <a:spcPts val="1000"/>
+              </a:spcAft>
+              <a:defRPr sz="2300">
+                <a:solidFill>
+                  <a:srgbClr val="232323"/>
+                </a:solidFill>
+              </a:defRPr>
+            </a:pPr>
+            <a:r>
+              <a:t>• підготовка звітів займає багато часу;</a:t>
+            </a:r>
+          </a:p>
+          <a:p>
+            <a:pPr>
+              <a:spcAft>
+                <a:spcPts val="1000"/>
+              </a:spcAft>
+              <a:defRPr sz="2300">
+                <a:solidFill>
+                  <a:srgbClr val="232323"/>
+                </a:solidFill>
+              </a:defRPr>
+            </a:pPr>
+            <a:r>
+              <a:t>• важко відстежувати зміни показників у динаміці.</a:t>
+            </a:r>
+          </a:p>
+        </p:txBody>
+      </p:sp>
+      <p:sp>
+        <p:nvSpPr>
+          <p:cNvPr id="4" name="TextBox 3"/>
           <p:cNvSpPr txBox="1"/>
           <p:nvPr/>
         </p:nvSpPr>
         <p:spPr>
           <a:xfrm>
-            <a:off x="11155680" y="6217920"/>
+            <a:off x="11247120" y="6309360"/>
             <a:ext cx="640080" cy="274320"/>
           </a:xfrm>
           <a:prstGeom prst="rect">
@@ -3712,11 +3551,7 @@
           <a:lstStyle/>
           <a:p>
             <a:pPr algn="r">
-              <a:defRPr sz="1400">
-                <a:solidFill>
-                  <a:srgbClr val="505050"/>
-                </a:solidFill>
-              </a:defRPr>
+              <a:defRPr sz="1400"/>
             </a:pPr>
             <a:r>
               <a:t>2</a:t>
@@ -3735,6 +3570,14 @@
 <file path=ppt/slides/slide3.xml><?xml version="1.0" encoding="utf-8"?>
 <p:sld xmlns:a="http://schemas.openxmlformats.org/drawingml/2006/main" xmlns:p="http://schemas.openxmlformats.org/presentationml/2006/main" xmlns:r="http://schemas.openxmlformats.org/officeDocument/2006/relationships">
   <p:cSld>
+    <p:bg>
+      <p:bgPr>
+        <a:solidFill>
+          <a:srgbClr val="F5F8FC"/>
+        </a:solidFill>
+        <a:effectLst/>
+      </p:bgPr>
+    </p:bg>
     <p:spTree>
       <p:nvGrpSpPr>
         <p:cNvPr id="1" name=""/>
@@ -3744,59 +3587,14 @@
       <p:grpSpPr/>
       <p:sp>
         <p:nvSpPr>
-          <p:cNvPr id="2" name="Rectangle 1"/>
-          <p:cNvSpPr/>
-          <p:nvPr/>
-        </p:nvSpPr>
-        <p:spPr>
-          <a:xfrm>
-            <a:off x="0" y="0"/>
-            <a:ext cx="12191695" cy="6858000"/>
-          </a:xfrm>
-          <a:prstGeom prst="rect">
-            <a:avLst/>
-          </a:prstGeom>
-          <a:solidFill>
-            <a:srgbClr val="F5F7FB"/>
-          </a:solidFill>
-          <a:ln>
-            <a:solidFill>
-              <a:srgbClr val="F5F7FB"/>
-            </a:solidFill>
-          </a:ln>
-        </p:spPr>
-        <p:style>
-          <a:lnRef idx="1">
-            <a:schemeClr val="accent1"/>
-          </a:lnRef>
-          <a:fillRef idx="3">
-            <a:schemeClr val="accent1"/>
-          </a:fillRef>
-          <a:effectRef idx="2">
-            <a:schemeClr val="accent1"/>
-          </a:effectRef>
-          <a:fontRef idx="minor">
-            <a:schemeClr val="lt1"/>
-          </a:fontRef>
-        </p:style>
-        <p:txBody>
-          <a:bodyPr rtlCol="0" anchor="ctr"/>
-          <a:lstStyle/>
-          <a:p>
-            <a:pPr algn="ctr"/>
-          </a:p>
-        </p:txBody>
-      </p:sp>
-      <p:sp>
-        <p:nvSpPr>
-          <p:cNvPr id="3" name="TextBox 2"/>
+          <p:cNvPr id="2" name="TextBox 1"/>
           <p:cNvSpPr txBox="1"/>
           <p:nvPr/>
         </p:nvSpPr>
         <p:spPr>
           <a:xfrm>
-            <a:off x="640080" y="457200"/>
-            <a:ext cx="10972800" cy="731520"/>
+            <a:off x="548640" y="365760"/>
+            <a:ext cx="10972800" cy="640080"/>
           </a:xfrm>
           <a:prstGeom prst="rect">
             <a:avLst/>
@@ -3810,11 +3608,10 @@
           <a:lstStyle/>
           <a:p>
             <a:pPr>
-              <a:defRPr sz="3200" b="1">
-                <a:solidFill>
-                  <a:srgbClr val="1F3B60"/>
-                </a:solidFill>
-                <a:latin typeface="Aptos Display"/>
+              <a:defRPr sz="3000" b="1">
+                <a:solidFill>
+                  <a:srgbClr val="14375A"/>
+                </a:solidFill>
               </a:defRPr>
             </a:pPr>
             <a:r>
@@ -3825,59 +3622,14 @@
       </p:sp>
       <p:sp>
         <p:nvSpPr>
-          <p:cNvPr id="4" name="Rectangle 3"/>
-          <p:cNvSpPr/>
-          <p:nvPr/>
-        </p:nvSpPr>
-        <p:spPr>
-          <a:xfrm>
-            <a:off x="731520" y="1417320"/>
-            <a:ext cx="10744200" cy="4389120"/>
-          </a:xfrm>
-          <a:prstGeom prst="rect">
-            <a:avLst/>
-          </a:prstGeom>
-          <a:solidFill>
-            <a:srgbClr val="FFFFFF"/>
-          </a:solidFill>
-          <a:ln>
-            <a:solidFill>
-              <a:srgbClr val="BECDE1"/>
-            </a:solidFill>
-          </a:ln>
-        </p:spPr>
-        <p:style>
-          <a:lnRef idx="1">
-            <a:schemeClr val="accent1"/>
-          </a:lnRef>
-          <a:fillRef idx="3">
-            <a:schemeClr val="accent1"/>
-          </a:fillRef>
-          <a:effectRef idx="2">
-            <a:schemeClr val="accent1"/>
-          </a:effectRef>
-          <a:fontRef idx="minor">
-            <a:schemeClr val="lt1"/>
-          </a:fontRef>
-        </p:style>
-        <p:txBody>
-          <a:bodyPr rtlCol="0" anchor="ctr"/>
-          <a:lstStyle/>
-          <a:p>
-            <a:pPr algn="ctr"/>
-          </a:p>
-        </p:txBody>
-      </p:sp>
-      <p:sp>
-        <p:nvSpPr>
-          <p:cNvPr id="5" name="TextBox 4"/>
+          <p:cNvPr id="3" name="TextBox 2"/>
           <p:cNvSpPr txBox="1"/>
           <p:nvPr/>
         </p:nvSpPr>
         <p:spPr>
           <a:xfrm>
-            <a:off x="1005840" y="1691640"/>
-            <a:ext cx="10149840" cy="3749039"/>
+            <a:off x="822960" y="1371600"/>
+            <a:ext cx="10607040" cy="4480560"/>
           </a:xfrm>
           <a:prstGeom prst="rect">
             <a:avLst/>
@@ -3885,34 +3637,66 @@
           <a:noFill/>
         </p:spPr>
         <p:txBody>
-          <a:bodyPr wrap="square">
+          <a:bodyPr wrap="none">
             <a:spAutoFit/>
           </a:bodyPr>
           <a:lstStyle/>
           <a:p>
             <a:pPr>
-              <a:defRPr sz="2200">
-                <a:solidFill>
-                  <a:srgbClr val="1E1E1E"/>
-                </a:solidFill>
-                <a:latin typeface="Aptos"/>
-              </a:defRPr>
-            </a:pPr>
-            <a:r>
-              <a:t>Створити єдине середовище для збирання, перевірки, зберігання та аналізу даних про земельні, водні та лісові ресурси.</a:t>
-            </a:r>
-          </a:p>
-        </p:txBody>
-      </p:sp>
-      <p:sp>
-        <p:nvSpPr>
-          <p:cNvPr id="6" name="TextBox 5"/>
+              <a:spcAft>
+                <a:spcPts val="1000"/>
+              </a:spcAft>
+              <a:defRPr sz="2300">
+                <a:solidFill>
+                  <a:srgbClr val="232323"/>
+                </a:solidFill>
+              </a:defRPr>
+            </a:pPr>
+            <a:r>
+              <a:t>• централізувати дані про природні ресурси;</a:t>
+            </a:r>
+          </a:p>
+          <a:p>
+            <a:pPr>
+              <a:spcAft>
+                <a:spcPts val="1000"/>
+              </a:spcAft>
+              <a:defRPr sz="2300">
+                <a:solidFill>
+                  <a:srgbClr val="232323"/>
+                </a:solidFill>
+              </a:defRPr>
+            </a:pPr>
+            <a:r>
+              <a:t>• забезпечити перевірку, аналіз і звітність;</a:t>
+            </a:r>
+          </a:p>
+          <a:p>
+            <a:pPr>
+              <a:spcAft>
+                <a:spcPts val="1000"/>
+              </a:spcAft>
+              <a:defRPr sz="2300">
+                <a:solidFill>
+                  <a:srgbClr val="232323"/>
+                </a:solidFill>
+              </a:defRPr>
+            </a:pPr>
+            <a:r>
+              <a:t>• підтримати прийняття управлінських рішень.</a:t>
+            </a:r>
+          </a:p>
+        </p:txBody>
+      </p:sp>
+      <p:sp>
+        <p:nvSpPr>
+          <p:cNvPr id="4" name="TextBox 3"/>
           <p:cNvSpPr txBox="1"/>
           <p:nvPr/>
         </p:nvSpPr>
         <p:spPr>
           <a:xfrm>
-            <a:off x="11155680" y="6217920"/>
+            <a:off x="11247120" y="6309360"/>
             <a:ext cx="640080" cy="274320"/>
           </a:xfrm>
           <a:prstGeom prst="rect">
@@ -3927,11 +3711,7 @@
           <a:lstStyle/>
           <a:p>
             <a:pPr algn="r">
-              <a:defRPr sz="1400">
-                <a:solidFill>
-                  <a:srgbClr val="505050"/>
-                </a:solidFill>
-              </a:defRPr>
+              <a:defRPr sz="1400"/>
             </a:pPr>
             <a:r>
               <a:t>3</a:t>
@@ -3950,6 +3730,14 @@
 <file path=ppt/slides/slide4.xml><?xml version="1.0" encoding="utf-8"?>
 <p:sld xmlns:a="http://schemas.openxmlformats.org/drawingml/2006/main" xmlns:p="http://schemas.openxmlformats.org/presentationml/2006/main" xmlns:r="http://schemas.openxmlformats.org/officeDocument/2006/relationships">
   <p:cSld>
+    <p:bg>
+      <p:bgPr>
+        <a:solidFill>
+          <a:srgbClr val="F5F8FC"/>
+        </a:solidFill>
+        <a:effectLst/>
+      </p:bgPr>
+    </p:bg>
     <p:spTree>
       <p:nvGrpSpPr>
         <p:cNvPr id="1" name=""/>
@@ -3959,59 +3747,14 @@
       <p:grpSpPr/>
       <p:sp>
         <p:nvSpPr>
-          <p:cNvPr id="2" name="Rectangle 1"/>
-          <p:cNvSpPr/>
-          <p:nvPr/>
-        </p:nvSpPr>
-        <p:spPr>
-          <a:xfrm>
-            <a:off x="0" y="0"/>
-            <a:ext cx="12191695" cy="6858000"/>
-          </a:xfrm>
-          <a:prstGeom prst="rect">
-            <a:avLst/>
-          </a:prstGeom>
-          <a:solidFill>
-            <a:srgbClr val="F5F7FB"/>
-          </a:solidFill>
-          <a:ln>
-            <a:solidFill>
-              <a:srgbClr val="F5F7FB"/>
-            </a:solidFill>
-          </a:ln>
-        </p:spPr>
-        <p:style>
-          <a:lnRef idx="1">
-            <a:schemeClr val="accent1"/>
-          </a:lnRef>
-          <a:fillRef idx="3">
-            <a:schemeClr val="accent1"/>
-          </a:fillRef>
-          <a:effectRef idx="2">
-            <a:schemeClr val="accent1"/>
-          </a:effectRef>
-          <a:fontRef idx="minor">
-            <a:schemeClr val="lt1"/>
-          </a:fontRef>
-        </p:style>
-        <p:txBody>
-          <a:bodyPr rtlCol="0" anchor="ctr"/>
-          <a:lstStyle/>
-          <a:p>
-            <a:pPr algn="ctr"/>
-          </a:p>
-        </p:txBody>
-      </p:sp>
-      <p:sp>
-        <p:nvSpPr>
-          <p:cNvPr id="3" name="TextBox 2"/>
+          <p:cNvPr id="2" name="TextBox 1"/>
           <p:cNvSpPr txBox="1"/>
           <p:nvPr/>
         </p:nvSpPr>
         <p:spPr>
           <a:xfrm>
-            <a:off x="640080" y="457200"/>
-            <a:ext cx="10972800" cy="731520"/>
+            <a:off x="548640" y="365760"/>
+            <a:ext cx="10972800" cy="640080"/>
           </a:xfrm>
           <a:prstGeom prst="rect">
             <a:avLst/>
@@ -4025,74 +3768,28 @@
           <a:lstStyle/>
           <a:p>
             <a:pPr>
-              <a:defRPr sz="3200" b="1">
-                <a:solidFill>
-                  <a:srgbClr val="1F3B60"/>
-                </a:solidFill>
-                <a:latin typeface="Aptos Display"/>
-              </a:defRPr>
-            </a:pPr>
-            <a:r>
-              <a:t>Основні компоненти</a:t>
-            </a:r>
-          </a:p>
-        </p:txBody>
-      </p:sp>
-      <p:sp>
-        <p:nvSpPr>
-          <p:cNvPr id="4" name="Rectangle 3"/>
-          <p:cNvSpPr/>
-          <p:nvPr/>
-        </p:nvSpPr>
-        <p:spPr>
-          <a:xfrm>
-            <a:off x="731520" y="1417320"/>
-            <a:ext cx="10744200" cy="4389120"/>
-          </a:xfrm>
-          <a:prstGeom prst="rect">
-            <a:avLst/>
-          </a:prstGeom>
-          <a:solidFill>
-            <a:srgbClr val="FFFFFF"/>
-          </a:solidFill>
-          <a:ln>
-            <a:solidFill>
-              <a:srgbClr val="BECDE1"/>
-            </a:solidFill>
-          </a:ln>
-        </p:spPr>
-        <p:style>
-          <a:lnRef idx="1">
-            <a:schemeClr val="accent1"/>
-          </a:lnRef>
-          <a:fillRef idx="3">
-            <a:schemeClr val="accent1"/>
-          </a:fillRef>
-          <a:effectRef idx="2">
-            <a:schemeClr val="accent1"/>
-          </a:effectRef>
-          <a:fontRef idx="minor">
-            <a:schemeClr val="lt1"/>
-          </a:fontRef>
-        </p:style>
-        <p:txBody>
-          <a:bodyPr rtlCol="0" anchor="ctr"/>
-          <a:lstStyle/>
-          <a:p>
-            <a:pPr algn="ctr"/>
-          </a:p>
-        </p:txBody>
-      </p:sp>
-      <p:sp>
-        <p:nvSpPr>
-          <p:cNvPr id="5" name="TextBox 4"/>
+              <a:defRPr sz="3000" b="1">
+                <a:solidFill>
+                  <a:srgbClr val="14375A"/>
+                </a:solidFill>
+              </a:defRPr>
+            </a:pPr>
+            <a:r>
+              <a:t>Основні користувачі</a:t>
+            </a:r>
+          </a:p>
+        </p:txBody>
+      </p:sp>
+      <p:sp>
+        <p:nvSpPr>
+          <p:cNvPr id="3" name="TextBox 2"/>
           <p:cNvSpPr txBox="1"/>
           <p:nvPr/>
         </p:nvSpPr>
         <p:spPr>
           <a:xfrm>
-            <a:off x="1005840" y="1691640"/>
-            <a:ext cx="10149840" cy="3749039"/>
+            <a:off x="822960" y="1371600"/>
+            <a:ext cx="10607040" cy="4480560"/>
           </a:xfrm>
           <a:prstGeom prst="rect">
             <a:avLst/>
@@ -4100,99 +3797,81 @@
           <a:noFill/>
         </p:spPr>
         <p:txBody>
-          <a:bodyPr wrap="square">
+          <a:bodyPr wrap="none">
             <a:spAutoFit/>
           </a:bodyPr>
           <a:lstStyle/>
           <a:p>
             <a:pPr>
-              <a:defRPr sz="2200">
-                <a:solidFill>
-                  <a:srgbClr val="1E1E1E"/>
-                </a:solidFill>
-                <a:latin typeface="Aptos"/>
-              </a:defRPr>
-            </a:pPr>
-            <a:r>
-              <a:t>• Backend API</a:t>
+              <a:spcAft>
+                <a:spcPts val="1000"/>
+              </a:spcAft>
+              <a:defRPr sz="2300">
+                <a:solidFill>
+                  <a:srgbClr val="232323"/>
+                </a:solidFill>
+              </a:defRPr>
+            </a:pPr>
+            <a:r>
+              <a:t>• адміністратор;</a:t>
             </a:r>
           </a:p>
           <a:p>
             <a:pPr>
-              <a:defRPr sz="2200">
-                <a:solidFill>
-                  <a:srgbClr val="1E1E1E"/>
-                </a:solidFill>
-                <a:latin typeface="Aptos"/>
-              </a:defRPr>
-            </a:pPr>
-            <a:r>
-              <a:t>• База даних</a:t>
+              <a:spcAft>
+                <a:spcPts val="1000"/>
+              </a:spcAft>
+              <a:defRPr sz="2300">
+                <a:solidFill>
+                  <a:srgbClr val="232323"/>
+                </a:solidFill>
+              </a:defRPr>
+            </a:pPr>
+            <a:r>
+              <a:t>• оператор введення даних;</a:t>
             </a:r>
           </a:p>
           <a:p>
             <a:pPr>
-              <a:defRPr sz="2200">
-                <a:solidFill>
-                  <a:srgbClr val="1E1E1E"/>
-                </a:solidFill>
-                <a:latin typeface="Aptos"/>
-              </a:defRPr>
-            </a:pPr>
-            <a:r>
-              <a:t>• Web-застосунок</a:t>
+              <a:spcAft>
+                <a:spcPts val="1000"/>
+              </a:spcAft>
+              <a:defRPr sz="2300">
+                <a:solidFill>
+                  <a:srgbClr val="232323"/>
+                </a:solidFill>
+              </a:defRPr>
+            </a:pPr>
+            <a:r>
+              <a:t>• аналітик;</a:t>
             </a:r>
           </a:p>
           <a:p>
             <a:pPr>
-              <a:defRPr sz="2200">
-                <a:solidFill>
-                  <a:srgbClr val="1E1E1E"/>
-                </a:solidFill>
-                <a:latin typeface="Aptos"/>
-              </a:defRPr>
-            </a:pPr>
-            <a:r>
-              <a:t>• Мобільний застосунок</a:t>
-            </a:r>
-          </a:p>
-          <a:p>
-            <a:pPr>
-              <a:defRPr sz="2200">
-                <a:solidFill>
-                  <a:srgbClr val="1E1E1E"/>
-                </a:solidFill>
-                <a:latin typeface="Aptos"/>
-              </a:defRPr>
-            </a:pPr>
-            <a:r>
-              <a:t>• IoT-джерела даних</a:t>
-            </a:r>
-          </a:p>
-          <a:p>
-            <a:pPr>
-              <a:defRPr sz="2200">
-                <a:solidFill>
-                  <a:srgbClr val="1E1E1E"/>
-                </a:solidFill>
-                <a:latin typeface="Aptos"/>
-              </a:defRPr>
-            </a:pPr>
-            <a:r>
-              <a:t>• Механізми масштабування</a:t>
-            </a:r>
-          </a:p>
-        </p:txBody>
-      </p:sp>
-      <p:sp>
-        <p:nvSpPr>
-          <p:cNvPr id="6" name="TextBox 5"/>
+              <a:spcAft>
+                <a:spcPts val="1000"/>
+              </a:spcAft>
+              <a:defRPr sz="2300">
+                <a:solidFill>
+                  <a:srgbClr val="232323"/>
+                </a:solidFill>
+              </a:defRPr>
+            </a:pPr>
+            <a:r>
+              <a:t>• гість для перегляду відкритих даних.</a:t>
+            </a:r>
+          </a:p>
+        </p:txBody>
+      </p:sp>
+      <p:sp>
+        <p:nvSpPr>
+          <p:cNvPr id="4" name="TextBox 3"/>
           <p:cNvSpPr txBox="1"/>
           <p:nvPr/>
         </p:nvSpPr>
         <p:spPr>
           <a:xfrm>
-            <a:off x="11155680" y="6217920"/>
+            <a:off x="11247120" y="6309360"/>
             <a:ext cx="640080" cy="274320"/>
           </a:xfrm>
           <a:prstGeom prst="rect">
@@ -4207,11 +3886,7 @@
           <a:lstStyle/>
           <a:p>
             <a:pPr algn="r">
-              <a:defRPr sz="1400">
-                <a:solidFill>
-                  <a:srgbClr val="505050"/>
-                </a:solidFill>
-              </a:defRPr>
+              <a:defRPr sz="1400"/>
             </a:pPr>
             <a:r>
               <a:t>4</a:t>
@@ -4230,6 +3905,14 @@
 <file path=ppt/slides/slide5.xml><?xml version="1.0" encoding="utf-8"?>
 <p:sld xmlns:a="http://schemas.openxmlformats.org/drawingml/2006/main" xmlns:p="http://schemas.openxmlformats.org/presentationml/2006/main" xmlns:r="http://schemas.openxmlformats.org/officeDocument/2006/relationships">
   <p:cSld>
+    <p:bg>
+      <p:bgPr>
+        <a:solidFill>
+          <a:srgbClr val="F5F8FC"/>
+        </a:solidFill>
+        <a:effectLst/>
+      </p:bgPr>
+    </p:bg>
     <p:spTree>
       <p:nvGrpSpPr>
         <p:cNvPr id="1" name=""/>
@@ -4239,59 +3922,14 @@
       <p:grpSpPr/>
       <p:sp>
         <p:nvSpPr>
-          <p:cNvPr id="2" name="Rectangle 1"/>
-          <p:cNvSpPr/>
-          <p:nvPr/>
-        </p:nvSpPr>
-        <p:spPr>
-          <a:xfrm>
-            <a:off x="0" y="0"/>
-            <a:ext cx="12191695" cy="6858000"/>
-          </a:xfrm>
-          <a:prstGeom prst="rect">
-            <a:avLst/>
-          </a:prstGeom>
-          <a:solidFill>
-            <a:srgbClr val="F5F7FB"/>
-          </a:solidFill>
-          <a:ln>
-            <a:solidFill>
-              <a:srgbClr val="F5F7FB"/>
-            </a:solidFill>
-          </a:ln>
-        </p:spPr>
-        <p:style>
-          <a:lnRef idx="1">
-            <a:schemeClr val="accent1"/>
-          </a:lnRef>
-          <a:fillRef idx="3">
-            <a:schemeClr val="accent1"/>
-          </a:fillRef>
-          <a:effectRef idx="2">
-            <a:schemeClr val="accent1"/>
-          </a:effectRef>
-          <a:fontRef idx="minor">
-            <a:schemeClr val="lt1"/>
-          </a:fontRef>
-        </p:style>
-        <p:txBody>
-          <a:bodyPr rtlCol="0" anchor="ctr"/>
-          <a:lstStyle/>
-          <a:p>
-            <a:pPr algn="ctr"/>
-          </a:p>
-        </p:txBody>
-      </p:sp>
-      <p:sp>
-        <p:nvSpPr>
-          <p:cNvPr id="3" name="TextBox 2"/>
+          <p:cNvPr id="2" name="TextBox 1"/>
           <p:cNvSpPr txBox="1"/>
           <p:nvPr/>
         </p:nvSpPr>
         <p:spPr>
           <a:xfrm>
-            <a:off x="640080" y="457200"/>
-            <a:ext cx="10972800" cy="731520"/>
+            <a:off x="548640" y="365760"/>
+            <a:ext cx="10972800" cy="640080"/>
           </a:xfrm>
           <a:prstGeom prst="rect">
             <a:avLst/>
@@ -4305,74 +3943,28 @@
           <a:lstStyle/>
           <a:p>
             <a:pPr>
-              <a:defRPr sz="3200" b="1">
-                <a:solidFill>
-                  <a:srgbClr val="1F3B60"/>
-                </a:solidFill>
-                <a:latin typeface="Aptos Display"/>
-              </a:defRPr>
-            </a:pPr>
-            <a:r>
-              <a:t>Web-застосунок</a:t>
-            </a:r>
-          </a:p>
-        </p:txBody>
-      </p:sp>
-      <p:sp>
-        <p:nvSpPr>
-          <p:cNvPr id="4" name="Rectangle 3"/>
-          <p:cNvSpPr/>
-          <p:nvPr/>
-        </p:nvSpPr>
-        <p:spPr>
-          <a:xfrm>
-            <a:off x="731520" y="1417320"/>
-            <a:ext cx="10744200" cy="4389120"/>
-          </a:xfrm>
-          <a:prstGeom prst="rect">
-            <a:avLst/>
-          </a:prstGeom>
-          <a:solidFill>
-            <a:srgbClr val="FFFFFF"/>
-          </a:solidFill>
-          <a:ln>
-            <a:solidFill>
-              <a:srgbClr val="BECDE1"/>
-            </a:solidFill>
-          </a:ln>
-        </p:spPr>
-        <p:style>
-          <a:lnRef idx="1">
-            <a:schemeClr val="accent1"/>
-          </a:lnRef>
-          <a:fillRef idx="3">
-            <a:schemeClr val="accent1"/>
-          </a:fillRef>
-          <a:effectRef idx="2">
-            <a:schemeClr val="accent1"/>
-          </a:effectRef>
-          <a:fontRef idx="minor">
-            <a:schemeClr val="lt1"/>
-          </a:fontRef>
-        </p:style>
-        <p:txBody>
-          <a:bodyPr rtlCol="0" anchor="ctr"/>
-          <a:lstStyle/>
-          <a:p>
-            <a:pPr algn="ctr"/>
-          </a:p>
-        </p:txBody>
-      </p:sp>
-      <p:sp>
-        <p:nvSpPr>
-          <p:cNvPr id="5" name="TextBox 4"/>
+              <a:defRPr sz="3000" b="1">
+                <a:solidFill>
+                  <a:srgbClr val="14375A"/>
+                </a:solidFill>
+              </a:defRPr>
+            </a:pPr>
+            <a:r>
+              <a:t>Архітектура системи</a:t>
+            </a:r>
+          </a:p>
+        </p:txBody>
+      </p:sp>
+      <p:sp>
+        <p:nvSpPr>
+          <p:cNvPr id="3" name="TextBox 2"/>
           <p:cNvSpPr txBox="1"/>
           <p:nvPr/>
         </p:nvSpPr>
         <p:spPr>
           <a:xfrm>
-            <a:off x="1005840" y="1691640"/>
-            <a:ext cx="10149840" cy="3749039"/>
+            <a:off x="822960" y="1371600"/>
+            <a:ext cx="10607040" cy="4480560"/>
           </a:xfrm>
           <a:prstGeom prst="rect">
             <a:avLst/>
@@ -4380,34 +3972,81 @@
           <a:noFill/>
         </p:spPr>
         <p:txBody>
-          <a:bodyPr wrap="square">
+          <a:bodyPr wrap="none">
             <a:spAutoFit/>
           </a:bodyPr>
           <a:lstStyle/>
           <a:p>
             <a:pPr>
-              <a:defRPr sz="2200">
-                <a:solidFill>
-                  <a:srgbClr val="1E1E1E"/>
-                </a:solidFill>
-                <a:latin typeface="Aptos"/>
-              </a:defRPr>
-            </a:pPr>
-            <a:r>
-              <a:t>Користувач переглядає аналітику та звіти. Адміністратор керує користувачами, даними, імпортом, експортом і резервним копіюванням.</a:t>
-            </a:r>
-          </a:p>
-        </p:txBody>
-      </p:sp>
-      <p:sp>
-        <p:nvSpPr>
-          <p:cNvPr id="6" name="TextBox 5"/>
+              <a:spcAft>
+                <a:spcPts val="1000"/>
+              </a:spcAft>
+              <a:defRPr sz="2300">
+                <a:solidFill>
+                  <a:srgbClr val="232323"/>
+                </a:solidFill>
+              </a:defRPr>
+            </a:pPr>
+            <a:r>
+              <a:t>• Web-клієнт для аналітики й адміністрування;</a:t>
+            </a:r>
+          </a:p>
+          <a:p>
+            <a:pPr>
+              <a:spcAft>
+                <a:spcPts val="1000"/>
+              </a:spcAft>
+              <a:defRPr sz="2300">
+                <a:solidFill>
+                  <a:srgbClr val="232323"/>
+                </a:solidFill>
+              </a:defRPr>
+            </a:pPr>
+            <a:r>
+              <a:t>• мобільний застосунок для польових даних;</a:t>
+            </a:r>
+          </a:p>
+          <a:p>
+            <a:pPr>
+              <a:spcAft>
+                <a:spcPts val="1000"/>
+              </a:spcAft>
+              <a:defRPr sz="2300">
+                <a:solidFill>
+                  <a:srgbClr val="232323"/>
+                </a:solidFill>
+              </a:defRPr>
+            </a:pPr>
+            <a:r>
+              <a:t>• backend API та база даних;</a:t>
+            </a:r>
+          </a:p>
+          <a:p>
+            <a:pPr>
+              <a:spcAft>
+                <a:spcPts val="1000"/>
+              </a:spcAft>
+              <a:defRPr sz="2300">
+                <a:solidFill>
+                  <a:srgbClr val="232323"/>
+                </a:solidFill>
+              </a:defRPr>
+            </a:pPr>
+            <a:r>
+              <a:t>• IoT-канал отримання вимірювань.</a:t>
+            </a:r>
+          </a:p>
+        </p:txBody>
+      </p:sp>
+      <p:sp>
+        <p:nvSpPr>
+          <p:cNvPr id="4" name="TextBox 3"/>
           <p:cNvSpPr txBox="1"/>
           <p:nvPr/>
         </p:nvSpPr>
         <p:spPr>
           <a:xfrm>
-            <a:off x="11155680" y="6217920"/>
+            <a:off x="11247120" y="6309360"/>
             <a:ext cx="640080" cy="274320"/>
           </a:xfrm>
           <a:prstGeom prst="rect">
@@ -4422,11 +4061,7 @@
           <a:lstStyle/>
           <a:p>
             <a:pPr algn="r">
-              <a:defRPr sz="1400">
-                <a:solidFill>
-                  <a:srgbClr val="505050"/>
-                </a:solidFill>
-              </a:defRPr>
+              <a:defRPr sz="1400"/>
             </a:pPr>
             <a:r>
               <a:t>5</a:t>
@@ -4445,6 +4080,14 @@
 <file path=ppt/slides/slide6.xml><?xml version="1.0" encoding="utf-8"?>
 <p:sld xmlns:a="http://schemas.openxmlformats.org/drawingml/2006/main" xmlns:p="http://schemas.openxmlformats.org/presentationml/2006/main" xmlns:r="http://schemas.openxmlformats.org/officeDocument/2006/relationships">
   <p:cSld>
+    <p:bg>
+      <p:bgPr>
+        <a:solidFill>
+          <a:srgbClr val="F5F8FC"/>
+        </a:solidFill>
+        <a:effectLst/>
+      </p:bgPr>
+    </p:bg>
     <p:spTree>
       <p:nvGrpSpPr>
         <p:cNvPr id="1" name=""/>
@@ -4454,59 +4097,14 @@
       <p:grpSpPr/>
       <p:sp>
         <p:nvSpPr>
-          <p:cNvPr id="2" name="Rectangle 1"/>
-          <p:cNvSpPr/>
-          <p:nvPr/>
-        </p:nvSpPr>
-        <p:spPr>
-          <a:xfrm>
-            <a:off x="0" y="0"/>
-            <a:ext cx="12191695" cy="6858000"/>
-          </a:xfrm>
-          <a:prstGeom prst="rect">
-            <a:avLst/>
-          </a:prstGeom>
-          <a:solidFill>
-            <a:srgbClr val="F5F7FB"/>
-          </a:solidFill>
-          <a:ln>
-            <a:solidFill>
-              <a:srgbClr val="F5F7FB"/>
-            </a:solidFill>
-          </a:ln>
-        </p:spPr>
-        <p:style>
-          <a:lnRef idx="1">
-            <a:schemeClr val="accent1"/>
-          </a:lnRef>
-          <a:fillRef idx="3">
-            <a:schemeClr val="accent1"/>
-          </a:fillRef>
-          <a:effectRef idx="2">
-            <a:schemeClr val="accent1"/>
-          </a:effectRef>
-          <a:fontRef idx="minor">
-            <a:schemeClr val="lt1"/>
-          </a:fontRef>
-        </p:style>
-        <p:txBody>
-          <a:bodyPr rtlCol="0" anchor="ctr"/>
-          <a:lstStyle/>
-          <a:p>
-            <a:pPr algn="ctr"/>
-          </a:p>
-        </p:txBody>
-      </p:sp>
-      <p:sp>
-        <p:nvSpPr>
-          <p:cNvPr id="3" name="TextBox 2"/>
+          <p:cNvPr id="2" name="TextBox 1"/>
           <p:cNvSpPr txBox="1"/>
           <p:nvPr/>
         </p:nvSpPr>
         <p:spPr>
           <a:xfrm>
-            <a:off x="640080" y="457200"/>
-            <a:ext cx="10972800" cy="731520"/>
+            <a:off x="548640" y="365760"/>
+            <a:ext cx="10972800" cy="640080"/>
           </a:xfrm>
           <a:prstGeom prst="rect">
             <a:avLst/>
@@ -4520,74 +4118,28 @@
           <a:lstStyle/>
           <a:p>
             <a:pPr>
-              <a:defRPr sz="3200" b="1">
-                <a:solidFill>
-                  <a:srgbClr val="1F3B60"/>
-                </a:solidFill>
-                <a:latin typeface="Aptos Display"/>
-              </a:defRPr>
-            </a:pPr>
-            <a:r>
-              <a:t>Мобільний застосунок</a:t>
-            </a:r>
-          </a:p>
-        </p:txBody>
-      </p:sp>
-      <p:sp>
-        <p:nvSpPr>
-          <p:cNvPr id="4" name="Rectangle 3"/>
-          <p:cNvSpPr/>
-          <p:nvPr/>
-        </p:nvSpPr>
-        <p:spPr>
-          <a:xfrm>
-            <a:off x="731520" y="1417320"/>
-            <a:ext cx="10744200" cy="4389120"/>
-          </a:xfrm>
-          <a:prstGeom prst="rect">
-            <a:avLst/>
-          </a:prstGeom>
-          <a:solidFill>
-            <a:srgbClr val="FFFFFF"/>
-          </a:solidFill>
-          <a:ln>
-            <a:solidFill>
-              <a:srgbClr val="BECDE1"/>
-            </a:solidFill>
-          </a:ln>
-        </p:spPr>
-        <p:style>
-          <a:lnRef idx="1">
-            <a:schemeClr val="accent1"/>
-          </a:lnRef>
-          <a:fillRef idx="3">
-            <a:schemeClr val="accent1"/>
-          </a:fillRef>
-          <a:effectRef idx="2">
-            <a:schemeClr val="accent1"/>
-          </a:effectRef>
-          <a:fontRef idx="minor">
-            <a:schemeClr val="lt1"/>
-          </a:fontRef>
-        </p:style>
-        <p:txBody>
-          <a:bodyPr rtlCol="0" anchor="ctr"/>
-          <a:lstStyle/>
-          <a:p>
-            <a:pPr algn="ctr"/>
-          </a:p>
-        </p:txBody>
-      </p:sp>
-      <p:sp>
-        <p:nvSpPr>
-          <p:cNvPr id="5" name="TextBox 4"/>
+              <a:defRPr sz="3000" b="1">
+                <a:solidFill>
+                  <a:srgbClr val="14375A"/>
+                </a:solidFill>
+              </a:defRPr>
+            </a:pPr>
+            <a:r>
+              <a:t>Виконані функції</a:t>
+            </a:r>
+          </a:p>
+        </p:txBody>
+      </p:sp>
+      <p:sp>
+        <p:nvSpPr>
+          <p:cNvPr id="3" name="TextBox 2"/>
           <p:cNvSpPr txBox="1"/>
           <p:nvPr/>
         </p:nvSpPr>
         <p:spPr>
           <a:xfrm>
-            <a:off x="1005840" y="1691640"/>
-            <a:ext cx="10149840" cy="3749039"/>
+            <a:off x="822960" y="1371600"/>
+            <a:ext cx="10607040" cy="4480560"/>
           </a:xfrm>
           <a:prstGeom prst="rect">
             <a:avLst/>
@@ -4595,34 +4147,96 @@
           <a:noFill/>
         </p:spPr>
         <p:txBody>
-          <a:bodyPr wrap="square">
+          <a:bodyPr wrap="none">
             <a:spAutoFit/>
           </a:bodyPr>
           <a:lstStyle/>
           <a:p>
             <a:pPr>
-              <a:defRPr sz="2200">
-                <a:solidFill>
-                  <a:srgbClr val="1E1E1E"/>
-                </a:solidFill>
-                <a:latin typeface="Aptos"/>
-              </a:defRPr>
-            </a:pPr>
-            <a:r>
-              <a:t>Мобільний клієнт дозволяє переглядати показники, фільтрувати дані та додавати польові спостереження з координатами.</a:t>
-            </a:r>
-          </a:p>
-        </p:txBody>
-      </p:sp>
-      <p:sp>
-        <p:nvSpPr>
-          <p:cNvPr id="6" name="TextBox 5"/>
+              <a:spcAft>
+                <a:spcPts val="1000"/>
+              </a:spcAft>
+              <a:defRPr sz="2300">
+                <a:solidFill>
+                  <a:srgbClr val="232323"/>
+                </a:solidFill>
+              </a:defRPr>
+            </a:pPr>
+            <a:r>
+              <a:t>• довідники ресурсів і показників;</a:t>
+            </a:r>
+          </a:p>
+          <a:p>
+            <a:pPr>
+              <a:spcAft>
+                <a:spcPts val="1000"/>
+              </a:spcAft>
+              <a:defRPr sz="2300">
+                <a:solidFill>
+                  <a:srgbClr val="232323"/>
+                </a:solidFill>
+              </a:defRPr>
+            </a:pPr>
+            <a:r>
+              <a:t>• імпорт і введення даних;</a:t>
+            </a:r>
+          </a:p>
+          <a:p>
+            <a:pPr>
+              <a:spcAft>
+                <a:spcPts val="1000"/>
+              </a:spcAft>
+              <a:defRPr sz="2300">
+                <a:solidFill>
+                  <a:srgbClr val="232323"/>
+                </a:solidFill>
+              </a:defRPr>
+            </a:pPr>
+            <a:r>
+              <a:t>• фільтрація та аналітичні графіки;</a:t>
+            </a:r>
+          </a:p>
+          <a:p>
+            <a:pPr>
+              <a:spcAft>
+                <a:spcPts val="1000"/>
+              </a:spcAft>
+              <a:defRPr sz="2300">
+                <a:solidFill>
+                  <a:srgbClr val="232323"/>
+                </a:solidFill>
+              </a:defRPr>
+            </a:pPr>
+            <a:r>
+              <a:t>• експорт звітів;</a:t>
+            </a:r>
+          </a:p>
+          <a:p>
+            <a:pPr>
+              <a:spcAft>
+                <a:spcPts val="1000"/>
+              </a:spcAft>
+              <a:defRPr sz="2300">
+                <a:solidFill>
+                  <a:srgbClr val="232323"/>
+                </a:solidFill>
+              </a:defRPr>
+            </a:pPr>
+            <a:r>
+              <a:t>• рольовий доступ.</a:t>
+            </a:r>
+          </a:p>
+        </p:txBody>
+      </p:sp>
+      <p:sp>
+        <p:nvSpPr>
+          <p:cNvPr id="4" name="TextBox 3"/>
           <p:cNvSpPr txBox="1"/>
           <p:nvPr/>
         </p:nvSpPr>
         <p:spPr>
           <a:xfrm>
-            <a:off x="11155680" y="6217920"/>
+            <a:off x="11247120" y="6309360"/>
             <a:ext cx="640080" cy="274320"/>
           </a:xfrm>
           <a:prstGeom prst="rect">
@@ -4637,11 +4251,7 @@
           <a:lstStyle/>
           <a:p>
             <a:pPr algn="r">
-              <a:defRPr sz="1400">
-                <a:solidFill>
-                  <a:srgbClr val="505050"/>
-                </a:solidFill>
-              </a:defRPr>
+              <a:defRPr sz="1400"/>
             </a:pPr>
             <a:r>
               <a:t>6</a:t>
@@ -4660,6 +4270,14 @@
 <file path=ppt/slides/slide7.xml><?xml version="1.0" encoding="utf-8"?>
 <p:sld xmlns:a="http://schemas.openxmlformats.org/drawingml/2006/main" xmlns:p="http://schemas.openxmlformats.org/presentationml/2006/main" xmlns:r="http://schemas.openxmlformats.org/officeDocument/2006/relationships">
   <p:cSld>
+    <p:bg>
+      <p:bgPr>
+        <a:solidFill>
+          <a:srgbClr val="F5F8FC"/>
+        </a:solidFill>
+        <a:effectLst/>
+      </p:bgPr>
+    </p:bg>
     <p:spTree>
       <p:nvGrpSpPr>
         <p:cNvPr id="1" name=""/>
@@ -4669,59 +4287,14 @@
       <p:grpSpPr/>
       <p:sp>
         <p:nvSpPr>
-          <p:cNvPr id="2" name="Rectangle 1"/>
-          <p:cNvSpPr/>
-          <p:nvPr/>
-        </p:nvSpPr>
-        <p:spPr>
-          <a:xfrm>
-            <a:off x="0" y="0"/>
-            <a:ext cx="12191695" cy="6858000"/>
-          </a:xfrm>
-          <a:prstGeom prst="rect">
-            <a:avLst/>
-          </a:prstGeom>
-          <a:solidFill>
-            <a:srgbClr val="F5F7FB"/>
-          </a:solidFill>
-          <a:ln>
-            <a:solidFill>
-              <a:srgbClr val="F5F7FB"/>
-            </a:solidFill>
-          </a:ln>
-        </p:spPr>
-        <p:style>
-          <a:lnRef idx="1">
-            <a:schemeClr val="accent1"/>
-          </a:lnRef>
-          <a:fillRef idx="3">
-            <a:schemeClr val="accent1"/>
-          </a:fillRef>
-          <a:effectRef idx="2">
-            <a:schemeClr val="accent1"/>
-          </a:effectRef>
-          <a:fontRef idx="minor">
-            <a:schemeClr val="lt1"/>
-          </a:fontRef>
-        </p:style>
-        <p:txBody>
-          <a:bodyPr rtlCol="0" anchor="ctr"/>
-          <a:lstStyle/>
-          <a:p>
-            <a:pPr algn="ctr"/>
-          </a:p>
-        </p:txBody>
-      </p:sp>
-      <p:sp>
-        <p:nvSpPr>
-          <p:cNvPr id="3" name="TextBox 2"/>
+          <p:cNvPr id="2" name="TextBox 1"/>
           <p:cNvSpPr txBox="1"/>
           <p:nvPr/>
         </p:nvSpPr>
         <p:spPr>
           <a:xfrm>
-            <a:off x="640080" y="457200"/>
-            <a:ext cx="10972800" cy="731520"/>
+            <a:off x="548640" y="365760"/>
+            <a:ext cx="10972800" cy="640080"/>
           </a:xfrm>
           <a:prstGeom prst="rect">
             <a:avLst/>
@@ -4735,74 +4308,28 @@
           <a:lstStyle/>
           <a:p>
             <a:pPr>
-              <a:defRPr sz="3200" b="1">
-                <a:solidFill>
-                  <a:srgbClr val="1F3B60"/>
-                </a:solidFill>
-                <a:latin typeface="Aptos Display"/>
-              </a:defRPr>
-            </a:pPr>
-            <a:r>
-              <a:t>Масштабування backend</a:t>
-            </a:r>
-          </a:p>
-        </p:txBody>
-      </p:sp>
-      <p:sp>
-        <p:nvSpPr>
-          <p:cNvPr id="4" name="Rectangle 3"/>
-          <p:cNvSpPr/>
-          <p:nvPr/>
-        </p:nvSpPr>
-        <p:spPr>
-          <a:xfrm>
-            <a:off x="731520" y="1417320"/>
-            <a:ext cx="10744200" cy="4389120"/>
-          </a:xfrm>
-          <a:prstGeom prst="rect">
-            <a:avLst/>
-          </a:prstGeom>
-          <a:solidFill>
-            <a:srgbClr val="FFFFFF"/>
-          </a:solidFill>
-          <a:ln>
-            <a:solidFill>
-              <a:srgbClr val="BECDE1"/>
-            </a:solidFill>
-          </a:ln>
-        </p:spPr>
-        <p:style>
-          <a:lnRef idx="1">
-            <a:schemeClr val="accent1"/>
-          </a:lnRef>
-          <a:fillRef idx="3">
-            <a:schemeClr val="accent1"/>
-          </a:fillRef>
-          <a:effectRef idx="2">
-            <a:schemeClr val="accent1"/>
-          </a:effectRef>
-          <a:fontRef idx="minor">
-            <a:schemeClr val="lt1"/>
-          </a:fontRef>
-        </p:style>
-        <p:txBody>
-          <a:bodyPr rtlCol="0" anchor="ctr"/>
-          <a:lstStyle/>
-          <a:p>
-            <a:pPr algn="ctr"/>
-          </a:p>
-        </p:txBody>
-      </p:sp>
-      <p:sp>
-        <p:nvSpPr>
-          <p:cNvPr id="5" name="TextBox 4"/>
+              <a:defRPr sz="3000" b="1">
+                <a:solidFill>
+                  <a:srgbClr val="14375A"/>
+                </a:solidFill>
+              </a:defRPr>
+            </a:pPr>
+            <a:r>
+              <a:t>Мобільний і Web клієнти</a:t>
+            </a:r>
+          </a:p>
+        </p:txBody>
+      </p:sp>
+      <p:sp>
+        <p:nvSpPr>
+          <p:cNvPr id="3" name="TextBox 2"/>
           <p:cNvSpPr txBox="1"/>
           <p:nvPr/>
         </p:nvSpPr>
         <p:spPr>
           <a:xfrm>
-            <a:off x="1005840" y="1691640"/>
-            <a:ext cx="10149840" cy="3749039"/>
+            <a:off x="822960" y="1371600"/>
+            <a:ext cx="10607040" cy="4480560"/>
           </a:xfrm>
           <a:prstGeom prst="rect">
             <a:avLst/>
@@ -4810,34 +4337,66 @@
           <a:noFill/>
         </p:spPr>
         <p:txBody>
-          <a:bodyPr wrap="square">
+          <a:bodyPr wrap="none">
             <a:spAutoFit/>
           </a:bodyPr>
           <a:lstStyle/>
           <a:p>
             <a:pPr>
-              <a:defRPr sz="2200">
-                <a:solidFill>
-                  <a:srgbClr val="1E1E1E"/>
-                </a:solidFill>
-                <a:latin typeface="Aptos"/>
-              </a:defRPr>
-            </a:pPr>
-            <a:r>
-              <a:t>Backend API контейнеризовано, передбачено горизонтальне масштабування через Kubernetes, Load Balancer та Horizontal Pod Autoscaler.</a:t>
-            </a:r>
-          </a:p>
-        </p:txBody>
-      </p:sp>
-      <p:sp>
-        <p:nvSpPr>
-          <p:cNvPr id="6" name="TextBox 5"/>
+              <a:spcAft>
+                <a:spcPts val="1000"/>
+              </a:spcAft>
+              <a:defRPr sz="2300">
+                <a:solidFill>
+                  <a:srgbClr val="232323"/>
+                </a:solidFill>
+              </a:defRPr>
+            </a:pPr>
+            <a:r>
+              <a:t>• мобільний клієнт доповнює систему польовими записами;</a:t>
+            </a:r>
+          </a:p>
+          <a:p>
+            <a:pPr>
+              <a:spcAft>
+                <a:spcPts val="1000"/>
+              </a:spcAft>
+              <a:defRPr sz="2300">
+                <a:solidFill>
+                  <a:srgbClr val="232323"/>
+                </a:solidFill>
+              </a:defRPr>
+            </a:pPr>
+            <a:r>
+              <a:t>• Web-клієнт забезпечує повний аналіз і адміністрування;</a:t>
+            </a:r>
+          </a:p>
+          <a:p>
+            <a:pPr>
+              <a:spcAft>
+                <a:spcPts val="1000"/>
+              </a:spcAft>
+              <a:defRPr sz="2300">
+                <a:solidFill>
+                  <a:srgbClr val="232323"/>
+                </a:solidFill>
+              </a:defRPr>
+            </a:pPr>
+            <a:r>
+              <a:t>• підтримано українську й англійську локалізацію.</a:t>
+            </a:r>
+          </a:p>
+        </p:txBody>
+      </p:sp>
+      <p:sp>
+        <p:nvSpPr>
+          <p:cNvPr id="4" name="TextBox 3"/>
           <p:cNvSpPr txBox="1"/>
           <p:nvPr/>
         </p:nvSpPr>
         <p:spPr>
           <a:xfrm>
-            <a:off x="11155680" y="6217920"/>
+            <a:off x="11247120" y="6309360"/>
             <a:ext cx="640080" cy="274320"/>
           </a:xfrm>
           <a:prstGeom prst="rect">
@@ -4852,11 +4411,7 @@
           <a:lstStyle/>
           <a:p>
             <a:pPr algn="r">
-              <a:defRPr sz="1400">
-                <a:solidFill>
-                  <a:srgbClr val="505050"/>
-                </a:solidFill>
-              </a:defRPr>
+              <a:defRPr sz="1400"/>
             </a:pPr>
             <a:r>
               <a:t>7</a:t>
@@ -4875,6 +4430,14 @@
 <file path=ppt/slides/slide8.xml><?xml version="1.0" encoding="utf-8"?>
 <p:sld xmlns:a="http://schemas.openxmlformats.org/drawingml/2006/main" xmlns:p="http://schemas.openxmlformats.org/presentationml/2006/main" xmlns:r="http://schemas.openxmlformats.org/officeDocument/2006/relationships">
   <p:cSld>
+    <p:bg>
+      <p:bgPr>
+        <a:solidFill>
+          <a:srgbClr val="F5F8FC"/>
+        </a:solidFill>
+        <a:effectLst/>
+      </p:bgPr>
+    </p:bg>
     <p:spTree>
       <p:nvGrpSpPr>
         <p:cNvPr id="1" name=""/>
@@ -4884,59 +4447,14 @@
       <p:grpSpPr/>
       <p:sp>
         <p:nvSpPr>
-          <p:cNvPr id="2" name="Rectangle 1"/>
-          <p:cNvSpPr/>
-          <p:nvPr/>
-        </p:nvSpPr>
-        <p:spPr>
-          <a:xfrm>
-            <a:off x="0" y="0"/>
-            <a:ext cx="12191695" cy="6858000"/>
-          </a:xfrm>
-          <a:prstGeom prst="rect">
-            <a:avLst/>
-          </a:prstGeom>
-          <a:solidFill>
-            <a:srgbClr val="F5F7FB"/>
-          </a:solidFill>
-          <a:ln>
-            <a:solidFill>
-              <a:srgbClr val="F5F7FB"/>
-            </a:solidFill>
-          </a:ln>
-        </p:spPr>
-        <p:style>
-          <a:lnRef idx="1">
-            <a:schemeClr val="accent1"/>
-          </a:lnRef>
-          <a:fillRef idx="3">
-            <a:schemeClr val="accent1"/>
-          </a:fillRef>
-          <a:effectRef idx="2">
-            <a:schemeClr val="accent1"/>
-          </a:effectRef>
-          <a:fontRef idx="minor">
-            <a:schemeClr val="lt1"/>
-          </a:fontRef>
-        </p:style>
-        <p:txBody>
-          <a:bodyPr rtlCol="0" anchor="ctr"/>
-          <a:lstStyle/>
-          <a:p>
-            <a:pPr algn="ctr"/>
-          </a:p>
-        </p:txBody>
-      </p:sp>
-      <p:sp>
-        <p:nvSpPr>
-          <p:cNvPr id="3" name="TextBox 2"/>
+          <p:cNvPr id="2" name="TextBox 1"/>
           <p:cNvSpPr txBox="1"/>
           <p:nvPr/>
         </p:nvSpPr>
         <p:spPr>
           <a:xfrm>
-            <a:off x="640080" y="457200"/>
-            <a:ext cx="10972800" cy="731520"/>
+            <a:off x="548640" y="365760"/>
+            <a:ext cx="10972800" cy="640080"/>
           </a:xfrm>
           <a:prstGeom prst="rect">
             <a:avLst/>
@@ -4950,74 +4468,28 @@
           <a:lstStyle/>
           <a:p>
             <a:pPr>
-              <a:defRPr sz="3200" b="1">
-                <a:solidFill>
-                  <a:srgbClr val="1F3B60"/>
-                </a:solidFill>
-                <a:latin typeface="Aptos Display"/>
-              </a:defRPr>
-            </a:pPr>
-            <a:r>
-              <a:t>Виконані функції</a:t>
-            </a:r>
-          </a:p>
-        </p:txBody>
-      </p:sp>
-      <p:sp>
-        <p:nvSpPr>
-          <p:cNvPr id="4" name="Rectangle 3"/>
-          <p:cNvSpPr/>
-          <p:nvPr/>
-        </p:nvSpPr>
-        <p:spPr>
-          <a:xfrm>
-            <a:off x="731520" y="1417320"/>
-            <a:ext cx="10744200" cy="4389120"/>
-          </a:xfrm>
-          <a:prstGeom prst="rect">
-            <a:avLst/>
-          </a:prstGeom>
-          <a:solidFill>
-            <a:srgbClr val="FFFFFF"/>
-          </a:solidFill>
-          <a:ln>
-            <a:solidFill>
-              <a:srgbClr val="BECDE1"/>
-            </a:solidFill>
-          </a:ln>
-        </p:spPr>
-        <p:style>
-          <a:lnRef idx="1">
-            <a:schemeClr val="accent1"/>
-          </a:lnRef>
-          <a:fillRef idx="3">
-            <a:schemeClr val="accent1"/>
-          </a:fillRef>
-          <a:effectRef idx="2">
-            <a:schemeClr val="accent1"/>
-          </a:effectRef>
-          <a:fontRef idx="minor">
-            <a:schemeClr val="lt1"/>
-          </a:fontRef>
-        </p:style>
-        <p:txBody>
-          <a:bodyPr rtlCol="0" anchor="ctr"/>
-          <a:lstStyle/>
-          <a:p>
-            <a:pPr algn="ctr"/>
-          </a:p>
-        </p:txBody>
-      </p:sp>
-      <p:sp>
-        <p:nvSpPr>
-          <p:cNvPr id="5" name="TextBox 4"/>
+              <a:defRPr sz="3000" b="1">
+                <a:solidFill>
+                  <a:srgbClr val="14375A"/>
+                </a:solidFill>
+              </a:defRPr>
+            </a:pPr>
+            <a:r>
+              <a:t>Масштабування backend</a:t>
+            </a:r>
+          </a:p>
+        </p:txBody>
+      </p:sp>
+      <p:sp>
+        <p:nvSpPr>
+          <p:cNvPr id="3" name="TextBox 2"/>
           <p:cNvSpPr txBox="1"/>
           <p:nvPr/>
         </p:nvSpPr>
         <p:spPr>
           <a:xfrm>
-            <a:off x="1005840" y="1691640"/>
-            <a:ext cx="10149840" cy="3749039"/>
+            <a:off x="822960" y="1371600"/>
+            <a:ext cx="10607040" cy="4480560"/>
           </a:xfrm>
           <a:prstGeom prst="rect">
             <a:avLst/>
@@ -5025,34 +4497,81 @@
           <a:noFill/>
         </p:spPr>
         <p:txBody>
-          <a:bodyPr wrap="square">
+          <a:bodyPr wrap="none">
             <a:spAutoFit/>
           </a:bodyPr>
           <a:lstStyle/>
           <a:p>
             <a:pPr>
-              <a:defRPr sz="2200">
-                <a:solidFill>
-                  <a:srgbClr val="1E1E1E"/>
-                </a:solidFill>
-                <a:latin typeface="Aptos"/>
-              </a:defRPr>
-            </a:pPr>
-            <a:r>
-              <a:t>Розроблено архітектуру системи, матеріали Vision &amp; Scope, мобільний клієнт, web-клієнт, конфігурації масштабування та демонстраційні матеріали.</a:t>
-            </a:r>
-          </a:p>
-        </p:txBody>
-      </p:sp>
-      <p:sp>
-        <p:nvSpPr>
-          <p:cNvPr id="6" name="TextBox 5"/>
+              <a:spcAft>
+                <a:spcPts val="1000"/>
+              </a:spcAft>
+              <a:defRPr sz="2300">
+                <a:solidFill>
+                  <a:srgbClr val="232323"/>
+                </a:solidFill>
+              </a:defRPr>
+            </a:pPr>
+            <a:r>
+              <a:t>• горизонтальне масштабування інстансів;</a:t>
+            </a:r>
+          </a:p>
+          <a:p>
+            <a:pPr>
+              <a:spcAft>
+                <a:spcPts val="1000"/>
+              </a:spcAft>
+              <a:defRPr sz="2300">
+                <a:solidFill>
+                  <a:srgbClr val="232323"/>
+                </a:solidFill>
+              </a:defRPr>
+            </a:pPr>
+            <a:r>
+              <a:t>• Nginx як load balancer;</a:t>
+            </a:r>
+          </a:p>
+          <a:p>
+            <a:pPr>
+              <a:spcAft>
+                <a:spcPts val="1000"/>
+              </a:spcAft>
+              <a:defRPr sz="2300">
+                <a:solidFill>
+                  <a:srgbClr val="232323"/>
+                </a:solidFill>
+              </a:defRPr>
+            </a:pPr>
+            <a:r>
+              <a:t>• PostgreSQL як центральна база даних;</a:t>
+            </a:r>
+          </a:p>
+          <a:p>
+            <a:pPr>
+              <a:spcAft>
+                <a:spcPts val="1000"/>
+              </a:spcAft>
+              <a:defRPr sz="2300">
+                <a:solidFill>
+                  <a:srgbClr val="232323"/>
+                </a:solidFill>
+              </a:defRPr>
+            </a:pPr>
+            <a:r>
+              <a:t>• Redis для кешування аналітичних запитів.</a:t>
+            </a:r>
+          </a:p>
+        </p:txBody>
+      </p:sp>
+      <p:sp>
+        <p:nvSpPr>
+          <p:cNvPr id="4" name="TextBox 3"/>
           <p:cNvSpPr txBox="1"/>
           <p:nvPr/>
         </p:nvSpPr>
         <p:spPr>
           <a:xfrm>
-            <a:off x="11155680" y="6217920"/>
+            <a:off x="11247120" y="6309360"/>
             <a:ext cx="640080" cy="274320"/>
           </a:xfrm>
           <a:prstGeom prst="rect">
@@ -5067,11 +4586,7 @@
           <a:lstStyle/>
           <a:p>
             <a:pPr algn="r">
-              <a:defRPr sz="1400">
-                <a:solidFill>
-                  <a:srgbClr val="505050"/>
-                </a:solidFill>
-              </a:defRPr>
+              <a:defRPr sz="1400"/>
             </a:pPr>
             <a:r>
               <a:t>8</a:t>
@@ -5090,6 +4605,14 @@
 <file path=ppt/slides/slide9.xml><?xml version="1.0" encoding="utf-8"?>
 <p:sld xmlns:a="http://schemas.openxmlformats.org/drawingml/2006/main" xmlns:p="http://schemas.openxmlformats.org/presentationml/2006/main" xmlns:r="http://schemas.openxmlformats.org/officeDocument/2006/relationships">
   <p:cSld>
+    <p:bg>
+      <p:bgPr>
+        <a:solidFill>
+          <a:srgbClr val="F5F8FC"/>
+        </a:solidFill>
+        <a:effectLst/>
+      </p:bgPr>
+    </p:bg>
     <p:spTree>
       <p:nvGrpSpPr>
         <p:cNvPr id="1" name=""/>
@@ -5099,59 +4622,14 @@
       <p:grpSpPr/>
       <p:sp>
         <p:nvSpPr>
-          <p:cNvPr id="2" name="Rectangle 1"/>
-          <p:cNvSpPr/>
-          <p:nvPr/>
-        </p:nvSpPr>
-        <p:spPr>
-          <a:xfrm>
-            <a:off x="0" y="0"/>
-            <a:ext cx="12191695" cy="6858000"/>
-          </a:xfrm>
-          <a:prstGeom prst="rect">
-            <a:avLst/>
-          </a:prstGeom>
-          <a:solidFill>
-            <a:srgbClr val="F5F7FB"/>
-          </a:solidFill>
-          <a:ln>
-            <a:solidFill>
-              <a:srgbClr val="F5F7FB"/>
-            </a:solidFill>
-          </a:ln>
-        </p:spPr>
-        <p:style>
-          <a:lnRef idx="1">
-            <a:schemeClr val="accent1"/>
-          </a:lnRef>
-          <a:fillRef idx="3">
-            <a:schemeClr val="accent1"/>
-          </a:fillRef>
-          <a:effectRef idx="2">
-            <a:schemeClr val="accent1"/>
-          </a:effectRef>
-          <a:fontRef idx="minor">
-            <a:schemeClr val="lt1"/>
-          </a:fontRef>
-        </p:style>
-        <p:txBody>
-          <a:bodyPr rtlCol="0" anchor="ctr"/>
-          <a:lstStyle/>
-          <a:p>
-            <a:pPr algn="ctr"/>
-          </a:p>
-        </p:txBody>
-      </p:sp>
-      <p:sp>
-        <p:nvSpPr>
-          <p:cNvPr id="3" name="TextBox 2"/>
+          <p:cNvPr id="2" name="TextBox 1"/>
           <p:cNvSpPr txBox="1"/>
           <p:nvPr/>
         </p:nvSpPr>
         <p:spPr>
           <a:xfrm>
-            <a:off x="640080" y="457200"/>
-            <a:ext cx="10972800" cy="731520"/>
+            <a:off x="548640" y="365760"/>
+            <a:ext cx="10972800" cy="640080"/>
           </a:xfrm>
           <a:prstGeom prst="rect">
             <a:avLst/>
@@ -5165,11 +4643,10 @@
           <a:lstStyle/>
           <a:p>
             <a:pPr>
-              <a:defRPr sz="3200" b="1">
-                <a:solidFill>
-                  <a:srgbClr val="1F3B60"/>
-                </a:solidFill>
-                <a:latin typeface="Aptos Display"/>
+              <a:defRPr sz="3000" b="1">
+                <a:solidFill>
+                  <a:srgbClr val="14375A"/>
+                </a:solidFill>
               </a:defRPr>
             </a:pPr>
             <a:r>
@@ -5180,59 +4657,14 @@
       </p:sp>
       <p:sp>
         <p:nvSpPr>
-          <p:cNvPr id="4" name="Rectangle 3"/>
-          <p:cNvSpPr/>
-          <p:nvPr/>
-        </p:nvSpPr>
-        <p:spPr>
-          <a:xfrm>
-            <a:off x="731520" y="1417320"/>
-            <a:ext cx="10744200" cy="4389120"/>
-          </a:xfrm>
-          <a:prstGeom prst="rect">
-            <a:avLst/>
-          </a:prstGeom>
-          <a:solidFill>
-            <a:srgbClr val="FFFFFF"/>
-          </a:solidFill>
-          <a:ln>
-            <a:solidFill>
-              <a:srgbClr val="BECDE1"/>
-            </a:solidFill>
-          </a:ln>
-        </p:spPr>
-        <p:style>
-          <a:lnRef idx="1">
-            <a:schemeClr val="accent1"/>
-          </a:lnRef>
-          <a:fillRef idx="3">
-            <a:schemeClr val="accent1"/>
-          </a:fillRef>
-          <a:effectRef idx="2">
-            <a:schemeClr val="accent1"/>
-          </a:effectRef>
-          <a:fontRef idx="minor">
-            <a:schemeClr val="lt1"/>
-          </a:fontRef>
-        </p:style>
-        <p:txBody>
-          <a:bodyPr rtlCol="0" anchor="ctr"/>
-          <a:lstStyle/>
-          <a:p>
-            <a:pPr algn="ctr"/>
-          </a:p>
-        </p:txBody>
-      </p:sp>
-      <p:sp>
-        <p:nvSpPr>
-          <p:cNvPr id="5" name="TextBox 4"/>
+          <p:cNvPr id="3" name="TextBox 2"/>
           <p:cNvSpPr txBox="1"/>
           <p:nvPr/>
         </p:nvSpPr>
         <p:spPr>
           <a:xfrm>
-            <a:off x="1005840" y="1691640"/>
-            <a:ext cx="10149840" cy="3749039"/>
+            <a:off x="822960" y="1371600"/>
+            <a:ext cx="10607040" cy="4480560"/>
           </a:xfrm>
           <a:prstGeom prst="rect">
             <a:avLst/>
@@ -5240,34 +4672,81 @@
           <a:noFill/>
         </p:spPr>
         <p:txBody>
-          <a:bodyPr wrap="square">
+          <a:bodyPr wrap="none">
             <a:spAutoFit/>
           </a:bodyPr>
           <a:lstStyle/>
           <a:p>
             <a:pPr>
-              <a:defRPr sz="2200">
-                <a:solidFill>
-                  <a:srgbClr val="1E1E1E"/>
-                </a:solidFill>
-                <a:latin typeface="Aptos"/>
-              </a:defRPr>
-            </a:pPr>
-            <a:r>
-              <a:t>У наступних релізах можна додати ШІ для прогнозування, виявлення аномалій, аналізу супутникових знімків і рекомендацій для фахівців.</a:t>
-            </a:r>
-          </a:p>
-        </p:txBody>
-      </p:sp>
-      <p:sp>
-        <p:nvSpPr>
-          <p:cNvPr id="6" name="TextBox 5"/>
+              <a:spcAft>
+                <a:spcPts val="1000"/>
+              </a:spcAft>
+              <a:defRPr sz="2300">
+                <a:solidFill>
+                  <a:srgbClr val="232323"/>
+                </a:solidFill>
+              </a:defRPr>
+            </a:pPr>
+            <a:r>
+              <a:t>• інтеграція ШІ для виявлення аномалій;</a:t>
+            </a:r>
+          </a:p>
+          <a:p>
+            <a:pPr>
+              <a:spcAft>
+                <a:spcPts val="1000"/>
+              </a:spcAft>
+              <a:defRPr sz="2300">
+                <a:solidFill>
+                  <a:srgbClr val="232323"/>
+                </a:solidFill>
+              </a:defRPr>
+            </a:pPr>
+            <a:r>
+              <a:t>• прогнозування змін показників;</a:t>
+            </a:r>
+          </a:p>
+          <a:p>
+            <a:pPr>
+              <a:spcAft>
+                <a:spcPts val="1000"/>
+              </a:spcAft>
+              <a:defRPr sz="2300">
+                <a:solidFill>
+                  <a:srgbClr val="232323"/>
+                </a:solidFill>
+              </a:defRPr>
+            </a:pPr>
+            <a:r>
+              <a:t>• геоаналітика та карти;</a:t>
+            </a:r>
+          </a:p>
+          <a:p>
+            <a:pPr>
+              <a:spcAft>
+                <a:spcPts val="1000"/>
+              </a:spcAft>
+              <a:defRPr sz="2300">
+                <a:solidFill>
+                  <a:srgbClr val="232323"/>
+                </a:solidFill>
+              </a:defRPr>
+            </a:pPr>
+            <a:r>
+              <a:t>• підключення відкритих державних наборів даних.</a:t>
+            </a:r>
+          </a:p>
+        </p:txBody>
+      </p:sp>
+      <p:sp>
+        <p:nvSpPr>
+          <p:cNvPr id="4" name="TextBox 3"/>
           <p:cNvSpPr txBox="1"/>
           <p:nvPr/>
         </p:nvSpPr>
         <p:spPr>
           <a:xfrm>
-            <a:off x="11155680" y="6217920"/>
+            <a:off x="11247120" y="6309360"/>
             <a:ext cx="640080" cy="274320"/>
           </a:xfrm>
           <a:prstGeom prst="rect">
@@ -5282,11 +4761,7 @@
           <a:lstStyle/>
           <a:p>
             <a:pPr algn="r">
-              <a:defRPr sz="1400">
-                <a:solidFill>
-                  <a:srgbClr val="505050"/>
-                </a:solidFill>
-              </a:defRPr>
+              <a:defRPr sz="1400"/>
             </a:pPr>
             <a:r>
               <a:t>9</a:t>

</xml_diff>